<commit_message>
Fix slide 1: real numbering instead of typed prefix + bullet
demo/deck/build_deck.py: the four task paragraphs inherited the master's
buChar bullet AND carried a typed "1. " prefix, so each line showed both a
dot and a number. set_number_bullet()/set_no_bullet() write real a:buAutoNum
(arabicPeriod) on the tasks and a:buNone on the Commands paragraph via the
paragraph's own oxml pPr (python-pptx has no bullet API); typed prefixes
removed.

.gitignore: demo/deck/__pycache__/ (python running the script leaves one).

Proved with a LibreOffice headless render + pdftotext (1., 2., 3., 4., no
stray bullet, Commands unbulleted) and by inspecting slide1.xml directly.
</commit_message>
<xml_diff>
--- a/demo/deck/pls,fix Demo Deck.pptx
+++ b/demo/deck/pls,fix Demo Deck.pptx
@@ -3775,34 +3775,42 @@
           <a:lstStyle/>
           <a:p>
             <a:pPr>
+              <a:buFont typeface="+mj-lt"/>
+              <a:buAutoNum type="arabicPeriod"/>
               <a:defRPr sz="1800"/>
             </a:pPr>
             <a:r>
-              <a:t>1. P&amp;L table → Slide 2, Where = Whole slide</a:t>
+              <a:t>P&amp;L table → Slide 2, Where = Whole slide</a:t>
             </a:r>
           </a:p>
           <a:p>
             <a:pPr>
+              <a:buFont typeface="+mj-lt"/>
+              <a:buAutoNum type="arabicPeriod"/>
               <a:defRPr sz="1800"/>
             </a:pPr>
             <a:r>
-              <a:t>2. Revenue chart → Slide 3, Where = Left half</a:t>
+              <a:t>Revenue chart → Slide 3, Where = Left half</a:t>
             </a:r>
           </a:p>
           <a:p>
             <a:pPr>
+              <a:buFont typeface="+mj-lt"/>
+              <a:buAutoNum type="arabicPeriod"/>
               <a:defRPr sz="1800"/>
             </a:pPr>
             <a:r>
-              <a:t>3. Segment pie → Slide 3, Where = Right half</a:t>
+              <a:t>Segment pie → Slide 3, Where = Right half</a:t>
             </a:r>
           </a:p>
           <a:p>
             <a:pPr>
+              <a:buFont typeface="+mj-lt"/>
+              <a:buAutoNum type="arabicPeriod"/>
               <a:defRPr sz="1800"/>
             </a:pPr>
             <a:r>
-              <a:t>4. Picture from the Data sheet → Slide 4: select the empty placeholder, Where = Selected shape</a:t>
+              <a:t>Picture from the Data sheet → Slide 4: select the empty placeholder, Where = Selected shape</a:t>
             </a:r>
           </a:p>
           <a:p>
@@ -3810,6 +3818,7 @@
               <a:spcBef>
                 <a:spcPts val="2000"/>
               </a:spcBef>
+              <a:buNone/>
             </a:pPr>
             <a:r>
               <a:rPr b="1" sz="1400"/>

</xml_diff>

<commit_message>
Fix title band to sit outside the pane's gap zone; center every title
demo/deck/build_deck.py: the title rule ended at 34 pt, so the pane's own
free-space scan (src/ppt/placement.ts occupiedBoxes + src/layout.ts
placeInFreeSpace, which blocks anything within GAP=12pt of a shape's bottom)
would read the first free top as 46 pt, not the 36 pt (CONTENT_TOP) slide 3
draws and the docstring promised. New TITLE_BAND_LIMIT = CONTENT_TOP - GAP
(24 pt) constant; title now sits at 0-18 pt, rule at 22-24 pt, on every
slide, so CONTENT_TOP reads as free the way the diagram claims.

add_title() also sets paragraph.alignment = PP_ALIGN.CENTER explicitly:
the "Picture with Caption" layout (slide 4) overrides the master's centered
title to left, so slide 4's title was the odd one out.

Rectangles on slide 3 unchanged (0.5in,0.5in,6.0833in,6.5in and
6.75in,0.5in,6.0833in,6.5in). unzip -t clean, grep -i signet still 0.
</commit_message>
<xml_diff>
--- a/demo/deck/pls,fix Demo Deck.pptx
+++ b/demo/deck/pls,fix Demo Deck.pptx
@@ -3733,16 +3733,16 @@
         </p:nvSpPr>
         <p:spPr>
           <a:xfrm>
-            <a:off x="457200" y="76200"/>
-            <a:ext cx="11277600" cy="304800"/>
+            <a:off x="457200" y="0"/>
+            <a:ext cx="11277600" cy="228600"/>
           </a:xfrm>
         </p:spPr>
         <p:txBody>
           <a:bodyPr/>
           <a:lstStyle/>
           <a:p>
-            <a:pPr>
-              <a:defRPr sz="2000" b="1">
+            <a:pPr algn="ctr">
+              <a:defRPr sz="1600" b="1">
                 <a:solidFill>
                   <a:srgbClr val="14213D"/>
                 </a:solidFill>
@@ -3839,7 +3839,7 @@
         </p:nvSpPr>
         <p:spPr>
           <a:xfrm>
-            <a:off x="457200" y="406400"/>
+            <a:off x="457200" y="279400"/>
             <a:ext cx="11277600" cy="25400"/>
           </a:xfrm>
           <a:prstGeom prst="rect">
@@ -3905,16 +3905,16 @@
         </p:nvSpPr>
         <p:spPr>
           <a:xfrm>
-            <a:off x="457200" y="76200"/>
-            <a:ext cx="11277600" cy="304800"/>
+            <a:off x="457200" y="0"/>
+            <a:ext cx="11277600" cy="228600"/>
           </a:xfrm>
         </p:spPr>
         <p:txBody>
           <a:bodyPr/>
           <a:lstStyle/>
           <a:p>
-            <a:pPr>
-              <a:defRPr sz="2000" b="1">
+            <a:pPr algn="ctr">
+              <a:defRPr sz="1600" b="1">
                 <a:solidFill>
                   <a:srgbClr val="14213D"/>
                 </a:solidFill>
@@ -3956,7 +3956,7 @@
         </p:nvSpPr>
         <p:spPr>
           <a:xfrm>
-            <a:off x="457200" y="406400"/>
+            <a:off x="457200" y="279400"/>
             <a:ext cx="11277600" cy="25400"/>
           </a:xfrm>
           <a:prstGeom prst="rect">
@@ -4022,16 +4022,16 @@
         </p:nvSpPr>
         <p:spPr>
           <a:xfrm>
-            <a:off x="457200" y="76200"/>
-            <a:ext cx="11277600" cy="304800"/>
+            <a:off x="457200" y="0"/>
+            <a:ext cx="11277600" cy="228600"/>
           </a:xfrm>
         </p:spPr>
         <p:txBody>
           <a:bodyPr/>
           <a:lstStyle/>
           <a:p>
-            <a:pPr>
-              <a:defRPr sz="2000" b="1">
+            <a:pPr algn="ctr">
+              <a:defRPr sz="1600" b="1">
                 <a:solidFill>
                   <a:srgbClr val="14213D"/>
                 </a:solidFill>
@@ -4051,7 +4051,7 @@
         </p:nvSpPr>
         <p:spPr>
           <a:xfrm>
-            <a:off x="457200" y="406400"/>
+            <a:off x="457200" y="279400"/>
             <a:ext cx="11277600" cy="25400"/>
           </a:xfrm>
           <a:prstGeom prst="rect">
@@ -4277,16 +4277,16 @@
         </p:nvSpPr>
         <p:spPr>
           <a:xfrm>
-            <a:off x="457200" y="76200"/>
-            <a:ext cx="11277600" cy="304800"/>
+            <a:off x="457200" y="0"/>
+            <a:ext cx="11277600" cy="228600"/>
           </a:xfrm>
         </p:spPr>
         <p:txBody>
           <a:bodyPr/>
           <a:lstStyle/>
           <a:p>
-            <a:pPr>
-              <a:defRPr sz="2000" b="1">
+            <a:pPr algn="ctr">
+              <a:defRPr sz="1600" b="1">
                 <a:solidFill>
                   <a:srgbClr val="14213D"/>
                 </a:solidFill>
@@ -4356,7 +4356,7 @@
         </p:nvSpPr>
         <p:spPr>
           <a:xfrm>
-            <a:off x="457200" y="406400"/>
+            <a:off x="457200" y="279400"/>
             <a:ext cx="11277600" cy="25400"/>
           </a:xfrm>
           <a:prstGeom prst="rect">

</xml_diff>

<commit_message>
Derive slide 4's caption band, stamp real timestamps, drop template baggage
demo/deck/build_deck.py:
- CAPTION_HEIGHT (one named constant) plus GAP now derive PICTURE_HEIGHT and
  CAPTION_TOP for slide 4, replacing the hand-tuned Pt(60)/Pt(48)/Pt(40).
  Ties out exactly: picture height + GAP + CAPTION_HEIGHT = CONTENT_HEIGHT
  (416 + 12 + 40 = 468 pt), verified after rebuild.
- set_core_properties() now stamps created/modified at build time instead of
  carrying python-pptx's 2013 template dates.
- New drop_template_baggage(): drops the one relationship each to
  docProps/thumbnail.jpeg (stale 4:3 preview) and
  ppt/printerSettings/printerSettings1.bin, so OpcPackage's reachability walk
  excludes both parts and their [Content_Types].xml entries on save - no zip
  surgery. Part count 31 -> 29, unzip -t clean, reload round-trip clean.
</commit_message>
<xml_diff>
--- a/demo/deck/pls,fix Demo Deck.pptx
+++ b/demo/deck/pls,fix Demo Deck.pptx
@@ -4311,7 +4311,7 @@
         <p:spPr>
           <a:xfrm>
             <a:off x="457200" y="457200"/>
-            <a:ext cx="11277600" cy="5181600"/>
+            <a:ext cx="11277600" cy="5283200"/>
           </a:xfrm>
         </p:spPr>
       </p:sp>
@@ -4327,7 +4327,7 @@
         </p:nvSpPr>
         <p:spPr>
           <a:xfrm>
-            <a:off x="457200" y="5791200"/>
+            <a:off x="457200" y="5892800"/>
             <a:ext cx="11277600" cy="508000"/>
           </a:xfrm>
         </p:spPr>

</xml_diff>

<commit_message>
Fix slide 4's clipped title: explicit anchor/insets, taller band
demo/deck/build_deck.py: "Picture with Caption" bottom-anchors its title
placeholder with a bottom inset; on an 18 pt box that pushed a 16 pt line's
ink about 4 pt above the slide's top edge (invisible/clipped). add_title()
now sets text_frame.vertical_anchor = MSO_ANCHOR.TOP and margin_top =
margin_bottom = 0 on every slide (no layout anchoring inherited anywhere),
and TITLE_HEIGHT is now derived as TITLE_BAND_LIMIT - RULE_HEIGHT (22 pt,
up from 18) so the taller line box still fits before the rule at 22-24 pt.

Proved with a LibreOffice render rasterized to PNG (200 dpi) and scanned for
navy ink: all four slides show ink at 4.68-18.00 pt (15.48 pt on slide 2,
which has no descenders) - slide 4 now matches slides 1 and 3 exactly,
comfortably inside 0..22 pt with no ink cut off at the top.
</commit_message>
<xml_diff>
--- a/demo/deck/pls,fix Demo Deck.pptx
+++ b/demo/deck/pls,fix Demo Deck.pptx
@@ -3734,11 +3734,11 @@
         <p:spPr>
           <a:xfrm>
             <a:off x="457200" y="0"/>
-            <a:ext cx="11277600" cy="228600"/>
+            <a:ext cx="11277600" cy="279400"/>
           </a:xfrm>
         </p:spPr>
         <p:txBody>
-          <a:bodyPr/>
+          <a:bodyPr anchor="t" tIns="0" bIns="0"/>
           <a:lstStyle/>
           <a:p>
             <a:pPr algn="ctr">
@@ -3906,11 +3906,11 @@
         <p:spPr>
           <a:xfrm>
             <a:off x="457200" y="0"/>
-            <a:ext cx="11277600" cy="228600"/>
+            <a:ext cx="11277600" cy="279400"/>
           </a:xfrm>
         </p:spPr>
         <p:txBody>
-          <a:bodyPr/>
+          <a:bodyPr anchor="t" tIns="0" bIns="0"/>
           <a:lstStyle/>
           <a:p>
             <a:pPr algn="ctr">
@@ -4023,11 +4023,11 @@
         <p:spPr>
           <a:xfrm>
             <a:off x="457200" y="0"/>
-            <a:ext cx="11277600" cy="228600"/>
+            <a:ext cx="11277600" cy="279400"/>
           </a:xfrm>
         </p:spPr>
         <p:txBody>
-          <a:bodyPr/>
+          <a:bodyPr anchor="t" tIns="0" bIns="0"/>
           <a:lstStyle/>
           <a:p>
             <a:pPr algn="ctr">
@@ -4278,11 +4278,11 @@
         <p:spPr>
           <a:xfrm>
             <a:off x="457200" y="0"/>
-            <a:ext cx="11277600" cy="228600"/>
+            <a:ext cx="11277600" cy="279400"/>
           </a:xfrm>
         </p:spPr>
         <p:txBody>
-          <a:bodyPr/>
+          <a:bodyPr anchor="t" tIns="0" bIns="0"/>
           <a:lstStyle/>
           <a:p>
             <a:pPr algn="ctr">

</xml_diff>